<commit_message>
Aufgaben und Präsentation aktualisiert
</commit_message>
<xml_diff>
--- a/Einführung in Git und Github.pptx
+++ b/Einführung in Git und Github.pptx
@@ -6464,7 +6464,7 @@
         <p:spPr/>
         <p:txBody>
           <a:bodyPr>
-            <a:normAutofit/>
+            <a:normAutofit fontScale="92500" lnSpcReduction="10000"/>
           </a:bodyPr>
           <a:lstStyle/>
           <a:p>
@@ -6591,7 +6591,7 @@
             </a:pPr>
             <a:r>
               <a:rPr lang="en-US" dirty="0"/>
-              <a:t>git status	</a:t>
+              <a:t>git status		</a:t>
             </a:r>
             <a:r>
               <a:rPr lang="de-DE" dirty="0"/>
@@ -6631,6 +6631,31 @@
             <a:r>
               <a:rPr lang="de-DE" dirty="0" err="1"/>
               <a:t>branch</a:t>
+            </a:r>
+            <a:r>
+              <a:rPr lang="de-DE" dirty="0"/>
+              <a:t>	Erstellt einen neuen Branch / zeigt </a:t>
+            </a:r>
+            <a:r>
+              <a:rPr lang="de-DE" dirty="0" err="1"/>
+              <a:t>Branches</a:t>
+            </a:r>
+            <a:r>
+              <a:rPr lang="de-DE" dirty="0"/>
+              <a:t> an</a:t>
+            </a:r>
+          </a:p>
+          <a:p>
+            <a:pPr marL="0" indent="0">
+              <a:buNone/>
+            </a:pPr>
+            <a:r>
+              <a:rPr lang="en-US" dirty="0"/>
+              <a:t>git switch	</a:t>
+            </a:r>
+            <a:r>
+              <a:rPr lang="de-DE" dirty="0"/>
+              <a:t>Wechselt zu einem anderen Branch</a:t>
             </a:r>
             <a:endParaRPr lang="en-US" dirty="0"/>
           </a:p>

</xml_diff>